<commit_message>
Full Data Reduced estimators and Depth
</commit_message>
<xml_diff>
--- a/Presentation Slides/FYP Presentation.pptx
+++ b/Presentation Slides/FYP Presentation.pptx
@@ -5,7 +5,7 @@
     <p:sldMasterId id="2147483659" r:id="rId1"/>
   </p:sldMasterIdLst>
   <p:notesMasterIdLst>
-    <p:notesMasterId r:id="rId25"/>
+    <p:notesMasterId r:id="rId28"/>
   </p:notesMasterIdLst>
   <p:sldIdLst>
     <p:sldId id="256" r:id="rId2"/>
@@ -31,23 +31,26 @@
     <p:sldId id="278" r:id="rId22"/>
     <p:sldId id="279" r:id="rId23"/>
     <p:sldId id="280" r:id="rId24"/>
+    <p:sldId id="282" r:id="rId25"/>
+    <p:sldId id="283" r:id="rId26"/>
+    <p:sldId id="281" r:id="rId27"/>
   </p:sldIdLst>
   <p:sldSz cx="9144000" cy="5143500" type="screen16x9"/>
   <p:notesSz cx="6858000" cy="9144000"/>
   <p:embeddedFontLst>
     <p:embeddedFont>
       <p:font typeface="Lato" panose="020F0502020204030203" pitchFamily="34" charset="0"/>
-      <p:regular r:id="rId26"/>
-      <p:bold r:id="rId27"/>
-      <p:italic r:id="rId28"/>
-      <p:boldItalic r:id="rId29"/>
+      <p:regular r:id="rId29"/>
+      <p:bold r:id="rId30"/>
+      <p:italic r:id="rId31"/>
+      <p:boldItalic r:id="rId32"/>
     </p:embeddedFont>
     <p:embeddedFont>
       <p:font typeface="Raleway" pitchFamily="2" charset="0"/>
-      <p:regular r:id="rId30"/>
-      <p:bold r:id="rId31"/>
-      <p:italic r:id="rId32"/>
-      <p:boldItalic r:id="rId33"/>
+      <p:regular r:id="rId33"/>
+      <p:bold r:id="rId34"/>
+      <p:italic r:id="rId35"/>
+      <p:boldItalic r:id="rId36"/>
     </p:embeddedFont>
   </p:embeddedFontLst>
   <p:defaultTextStyle>
@@ -301,7 +304,7 @@
 <file path=ppt/revisionInfo.xml><?xml version="1.0" encoding="utf-8"?>
 <p1510:revInfo xmlns:a="http://schemas.openxmlformats.org/drawingml/2006/main" xmlns:r="http://schemas.openxmlformats.org/officeDocument/2006/relationships" xmlns:p1510="http://schemas.microsoft.com/office/powerpoint/2015/10/main">
   <p1510:revLst>
-    <p1510:client id="{D5A6156F-3151-4AAB-B3B7-1C2EDB7FB276}" v="12" dt="2026-06-29T11:46:35.799"/>
+    <p1510:client id="{D5A6156F-3151-4AAB-B3B7-1C2EDB7FB276}" v="18" dt="2026-06-29T12:05:42.717"/>
   </p1510:revLst>
 </p1510:revInfo>
 </file>
@@ -311,7 +314,7 @@
   <pc:docChgLst>
     <pc:chgData name="Karthikeya Moleyar" userId="b51051ba856dafdf" providerId="LiveId" clId="{AB7CCA75-D7E2-42E3-A660-2E75CD62CFC8}"/>
     <pc:docChg chg="undo custSel addSld delSld modSld sldOrd">
-      <pc:chgData name="Karthikeya Moleyar" userId="b51051ba856dafdf" providerId="LiveId" clId="{AB7CCA75-D7E2-42E3-A660-2E75CD62CFC8}" dt="2026-06-29T11:48:40.287" v="1610" actId="20577"/>
+      <pc:chgData name="Karthikeya Moleyar" userId="b51051ba856dafdf" providerId="LiveId" clId="{AB7CCA75-D7E2-42E3-A660-2E75CD62CFC8}" dt="2026-06-29T12:43:01.722" v="2325" actId="20577"/>
       <pc:docMkLst>
         <pc:docMk/>
       </pc:docMkLst>
@@ -550,7 +553,7 @@
         </pc:spChg>
       </pc:sldChg>
       <pc:sldChg chg="addSp modSp new mod">
-        <pc:chgData name="Karthikeya Moleyar" userId="b51051ba856dafdf" providerId="LiveId" clId="{AB7CCA75-D7E2-42E3-A660-2E75CD62CFC8}" dt="2026-06-29T11:48:13.442" v="1536" actId="20577"/>
+        <pc:chgData name="Karthikeya Moleyar" userId="b51051ba856dafdf" providerId="LiveId" clId="{AB7CCA75-D7E2-42E3-A660-2E75CD62CFC8}" dt="2026-06-29T11:51:55.539" v="1673" actId="1076"/>
         <pc:sldMkLst>
           <pc:docMk/>
           <pc:sldMk cId="4161537304" sldId="278"/>
@@ -564,7 +567,7 @@
           </ac:spMkLst>
         </pc:spChg>
         <pc:spChg chg="mod">
-          <ac:chgData name="Karthikeya Moleyar" userId="b51051ba856dafdf" providerId="LiveId" clId="{AB7CCA75-D7E2-42E3-A660-2E75CD62CFC8}" dt="2026-06-29T11:43:29.445" v="1297" actId="20577"/>
+          <ac:chgData name="Karthikeya Moleyar" userId="b51051ba856dafdf" providerId="LiveId" clId="{AB7CCA75-D7E2-42E3-A660-2E75CD62CFC8}" dt="2026-06-29T11:51:52.718" v="1672"/>
           <ac:spMkLst>
             <pc:docMk/>
             <pc:sldMk cId="4161537304" sldId="278"/>
@@ -572,7 +575,7 @@
           </ac:spMkLst>
         </pc:spChg>
         <pc:picChg chg="add mod">
-          <ac:chgData name="Karthikeya Moleyar" userId="b51051ba856dafdf" providerId="LiveId" clId="{AB7CCA75-D7E2-42E3-A660-2E75CD62CFC8}" dt="2026-06-29T11:43:32.210" v="1299" actId="1076"/>
+          <ac:chgData name="Karthikeya Moleyar" userId="b51051ba856dafdf" providerId="LiveId" clId="{AB7CCA75-D7E2-42E3-A660-2E75CD62CFC8}" dt="2026-06-29T11:51:55.539" v="1673" actId="1076"/>
           <ac:picMkLst>
             <pc:docMk/>
             <pc:sldMk cId="4161537304" sldId="278"/>
@@ -603,8 +606,8 @@
           </ac:spMkLst>
         </pc:spChg>
       </pc:sldChg>
-      <pc:sldChg chg="modSp new mod">
-        <pc:chgData name="Karthikeya Moleyar" userId="b51051ba856dafdf" providerId="LiveId" clId="{AB7CCA75-D7E2-42E3-A660-2E75CD62CFC8}" dt="2026-06-29T11:48:40.287" v="1610" actId="20577"/>
+      <pc:sldChg chg="addSp modSp new mod">
+        <pc:chgData name="Karthikeya Moleyar" userId="b51051ba856dafdf" providerId="LiveId" clId="{AB7CCA75-D7E2-42E3-A660-2E75CD62CFC8}" dt="2026-06-29T11:53:49.027" v="1731" actId="1076"/>
         <pc:sldMkLst>
           <pc:docMk/>
           <pc:sldMk cId="1630137038" sldId="280"/>
@@ -618,13 +621,114 @@
           </ac:spMkLst>
         </pc:spChg>
         <pc:spChg chg="mod">
-          <ac:chgData name="Karthikeya Moleyar" userId="b51051ba856dafdf" providerId="LiveId" clId="{AB7CCA75-D7E2-42E3-A660-2E75CD62CFC8}" dt="2026-06-29T11:48:40.287" v="1610" actId="20577"/>
+          <ac:chgData name="Karthikeya Moleyar" userId="b51051ba856dafdf" providerId="LiveId" clId="{AB7CCA75-D7E2-42E3-A660-2E75CD62CFC8}" dt="2026-06-29T11:53:45.054" v="1729" actId="20577"/>
           <ac:spMkLst>
             <pc:docMk/>
             <pc:sldMk cId="1630137038" sldId="280"/>
             <ac:spMk id="3" creationId="{C3AC052B-3CC0-B4BC-C068-3F22FEF30484}"/>
           </ac:spMkLst>
         </pc:spChg>
+        <pc:picChg chg="add mod">
+          <ac:chgData name="Karthikeya Moleyar" userId="b51051ba856dafdf" providerId="LiveId" clId="{AB7CCA75-D7E2-42E3-A660-2E75CD62CFC8}" dt="2026-06-29T11:53:49.027" v="1731" actId="1076"/>
+          <ac:picMkLst>
+            <pc:docMk/>
+            <pc:sldMk cId="1630137038" sldId="280"/>
+            <ac:picMk id="5" creationId="{0AB5A529-501E-2519-F572-BC048B13DB02}"/>
+          </ac:picMkLst>
+        </pc:picChg>
+      </pc:sldChg>
+      <pc:sldChg chg="addSp delSp modSp new mod">
+        <pc:chgData name="Karthikeya Moleyar" userId="b51051ba856dafdf" providerId="LiveId" clId="{AB7CCA75-D7E2-42E3-A660-2E75CD62CFC8}" dt="2026-06-29T12:43:01.722" v="2325" actId="20577"/>
+        <pc:sldMkLst>
+          <pc:docMk/>
+          <pc:sldMk cId="2923701509" sldId="281"/>
+        </pc:sldMkLst>
+        <pc:spChg chg="mod">
+          <ac:chgData name="Karthikeya Moleyar" userId="b51051ba856dafdf" providerId="LiveId" clId="{AB7CCA75-D7E2-42E3-A660-2E75CD62CFC8}" dt="2026-06-29T12:03:49.881" v="2059" actId="20577"/>
+          <ac:spMkLst>
+            <pc:docMk/>
+            <pc:sldMk cId="2923701509" sldId="281"/>
+            <ac:spMk id="2" creationId="{3629E79B-02A5-4A95-6233-A7C48BEDD2B2}"/>
+          </ac:spMkLst>
+        </pc:spChg>
+        <pc:spChg chg="mod">
+          <ac:chgData name="Karthikeya Moleyar" userId="b51051ba856dafdf" providerId="LiveId" clId="{AB7CCA75-D7E2-42E3-A660-2E75CD62CFC8}" dt="2026-06-29T12:43:01.722" v="2325" actId="20577"/>
+          <ac:spMkLst>
+            <pc:docMk/>
+            <pc:sldMk cId="2923701509" sldId="281"/>
+            <ac:spMk id="3" creationId="{A5967385-7EF5-732F-439B-B496A8181E71}"/>
+          </ac:spMkLst>
+        </pc:spChg>
+        <pc:picChg chg="add del mod">
+          <ac:chgData name="Karthikeya Moleyar" userId="b51051ba856dafdf" providerId="LiveId" clId="{AB7CCA75-D7E2-42E3-A660-2E75CD62CFC8}" dt="2026-06-29T12:01:39.750" v="1815" actId="478"/>
+          <ac:picMkLst>
+            <pc:docMk/>
+            <pc:sldMk cId="2923701509" sldId="281"/>
+            <ac:picMk id="5" creationId="{869CFA29-AA16-713A-84D9-2C8D1ACB017B}"/>
+          </ac:picMkLst>
+        </pc:picChg>
+      </pc:sldChg>
+      <pc:sldChg chg="modSp new mod">
+        <pc:chgData name="Karthikeya Moleyar" userId="b51051ba856dafdf" providerId="LiveId" clId="{AB7CCA75-D7E2-42E3-A660-2E75CD62CFC8}" dt="2026-06-29T11:59:01.340" v="1809" actId="20577"/>
+        <pc:sldMkLst>
+          <pc:docMk/>
+          <pc:sldMk cId="3112262530" sldId="282"/>
+        </pc:sldMkLst>
+        <pc:spChg chg="mod">
+          <ac:chgData name="Karthikeya Moleyar" userId="b51051ba856dafdf" providerId="LiveId" clId="{AB7CCA75-D7E2-42E3-A660-2E75CD62CFC8}" dt="2026-06-29T11:58:24.964" v="1775" actId="20577"/>
+          <ac:spMkLst>
+            <pc:docMk/>
+            <pc:sldMk cId="3112262530" sldId="282"/>
+            <ac:spMk id="2" creationId="{22BDE856-C63A-4B10-4CFB-33E36F7C5A6A}"/>
+          </ac:spMkLst>
+        </pc:spChg>
+        <pc:spChg chg="mod">
+          <ac:chgData name="Karthikeya Moleyar" userId="b51051ba856dafdf" providerId="LiveId" clId="{AB7CCA75-D7E2-42E3-A660-2E75CD62CFC8}" dt="2026-06-29T11:59:01.340" v="1809" actId="20577"/>
+          <ac:spMkLst>
+            <pc:docMk/>
+            <pc:sldMk cId="3112262530" sldId="282"/>
+            <ac:spMk id="3" creationId="{33A31C01-004F-967D-4EF1-6C2233BA85E8}"/>
+          </ac:spMkLst>
+        </pc:spChg>
+      </pc:sldChg>
+      <pc:sldChg chg="addSp modSp new mod">
+        <pc:chgData name="Karthikeya Moleyar" userId="b51051ba856dafdf" providerId="LiveId" clId="{AB7CCA75-D7E2-42E3-A660-2E75CD62CFC8}" dt="2026-06-29T12:06:30.064" v="2201" actId="166"/>
+        <pc:sldMkLst>
+          <pc:docMk/>
+          <pc:sldMk cId="2945472335" sldId="283"/>
+        </pc:sldMkLst>
+        <pc:spChg chg="mod">
+          <ac:chgData name="Karthikeya Moleyar" userId="b51051ba856dafdf" providerId="LiveId" clId="{AB7CCA75-D7E2-42E3-A660-2E75CD62CFC8}" dt="2026-06-29T12:01:52.544" v="1855" actId="20577"/>
+          <ac:spMkLst>
+            <pc:docMk/>
+            <pc:sldMk cId="2945472335" sldId="283"/>
+            <ac:spMk id="2" creationId="{5227D442-719C-65AA-4470-9126BECBFB17}"/>
+          </ac:spMkLst>
+        </pc:spChg>
+        <pc:spChg chg="mod">
+          <ac:chgData name="Karthikeya Moleyar" userId="b51051ba856dafdf" providerId="LiveId" clId="{AB7CCA75-D7E2-42E3-A660-2E75CD62CFC8}" dt="2026-06-29T12:03:19.991" v="1992" actId="20577"/>
+          <ac:spMkLst>
+            <pc:docMk/>
+            <pc:sldMk cId="2945472335" sldId="283"/>
+            <ac:spMk id="3" creationId="{87E0656D-9CA4-CCF0-91E8-660097AB0EB5}"/>
+          </ac:spMkLst>
+        </pc:spChg>
+        <pc:picChg chg="add mod ord">
+          <ac:chgData name="Karthikeya Moleyar" userId="b51051ba856dafdf" providerId="LiveId" clId="{AB7CCA75-D7E2-42E3-A660-2E75CD62CFC8}" dt="2026-06-29T12:06:30.064" v="2201" actId="166"/>
+          <ac:picMkLst>
+            <pc:docMk/>
+            <pc:sldMk cId="2945472335" sldId="283"/>
+            <ac:picMk id="5" creationId="{F325F47F-0086-51C3-9877-EFA8F7258E08}"/>
+          </ac:picMkLst>
+        </pc:picChg>
+        <pc:picChg chg="add mod">
+          <ac:chgData name="Karthikeya Moleyar" userId="b51051ba856dafdf" providerId="LiveId" clId="{AB7CCA75-D7E2-42E3-A660-2E75CD62CFC8}" dt="2026-06-29T12:06:24.287" v="2199" actId="1076"/>
+          <ac:picMkLst>
+            <pc:docMk/>
+            <pc:sldMk cId="2945472335" sldId="283"/>
+            <ac:picMk id="7" creationId="{FEAB387D-8C0D-9CC4-83C4-9477FDBA3194}"/>
+          </ac:picMkLst>
+        </pc:picChg>
       </pc:sldChg>
     </pc:docChg>
   </pc:docChgLst>
@@ -11041,6 +11145,45 @@
             </a:r>
           </a:p>
           <a:p>
+            <a:r>
+              <a:rPr lang="en-US" dirty="0"/>
+              <a:t>Configuration:</a:t>
+            </a:r>
+          </a:p>
+          <a:p>
+            <a:r>
+              <a:rPr lang="en-US" dirty="0"/>
+              <a:t>- </a:t>
+            </a:r>
+            <a:r>
+              <a:rPr lang="en-US" dirty="0" err="1"/>
+              <a:t>n_neighbors</a:t>
+            </a:r>
+            <a:r>
+              <a:rPr lang="en-US" dirty="0"/>
+              <a:t>: 20</a:t>
+            </a:r>
+          </a:p>
+          <a:p>
+            <a:r>
+              <a:rPr lang="en-US" dirty="0"/>
+              <a:t>- contamination: 'auto'</a:t>
+            </a:r>
+          </a:p>
+          <a:p>
+            <a:r>
+              <a:rPr lang="en-US" dirty="0"/>
+              <a:t>- Same 7 features as Isolation Forest</a:t>
+            </a:r>
+          </a:p>
+          <a:p>
+            <a:r>
+              <a:rPr lang="en-US" dirty="0"/>
+              <a:t>- ROC-based threshold optimization</a:t>
+            </a:r>
+            <a:endParaRPr lang="en-IN" dirty="0"/>
+          </a:p>
+          <a:p>
             <a:endParaRPr lang="en-IN" dirty="0"/>
           </a:p>
           <a:p>
@@ -11070,7 +11213,7 @@
         </p:blipFill>
         <p:spPr>
           <a:xfrm>
-            <a:off x="1965041" y="2754540"/>
+            <a:off x="4210153" y="2657896"/>
             <a:ext cx="4054191" cy="2072820"/>
           </a:xfrm>
           <a:prstGeom prst="rect">
@@ -11268,8 +11411,282 @@
         </p:nvSpPr>
         <p:spPr/>
         <p:txBody>
+          <a:bodyPr>
+            <a:normAutofit fontScale="92500" lnSpcReduction="20000"/>
+          </a:bodyPr>
+          <a:lstStyle/>
+          <a:p>
+            <a:r>
+              <a:rPr lang="en-IN" dirty="0"/>
+              <a:t>Created Labelled Dataset and applied Random Forest </a:t>
+            </a:r>
+          </a:p>
+          <a:p>
+            <a:endParaRPr lang="en-IN" dirty="0"/>
+          </a:p>
+          <a:p>
+            <a:r>
+              <a:rPr lang="en-IN" dirty="0"/>
+              <a:t>Configuration:</a:t>
+            </a:r>
+          </a:p>
+          <a:p>
+            <a:r>
+              <a:rPr lang="en-IN" dirty="0"/>
+              <a:t>- </a:t>
+            </a:r>
+            <a:r>
+              <a:rPr lang="en-IN" dirty="0" err="1"/>
+              <a:t>n_estimators</a:t>
+            </a:r>
+            <a:r>
+              <a:rPr lang="en-IN" dirty="0"/>
+              <a:t>: 100</a:t>
+            </a:r>
+          </a:p>
+          <a:p>
+            <a:r>
+              <a:rPr lang="en-IN" dirty="0"/>
+              <a:t>- </a:t>
+            </a:r>
+            <a:r>
+              <a:rPr lang="en-IN" dirty="0" err="1"/>
+              <a:t>max_depth</a:t>
+            </a:r>
+            <a:r>
+              <a:rPr lang="en-IN" dirty="0"/>
+              <a:t>: 15</a:t>
+            </a:r>
+          </a:p>
+          <a:p>
+            <a:r>
+              <a:rPr lang="en-IN" dirty="0"/>
+              <a:t>- </a:t>
+            </a:r>
+            <a:r>
+              <a:rPr lang="en-IN" dirty="0" err="1"/>
+              <a:t>min_samples_split</a:t>
+            </a:r>
+            <a:r>
+              <a:rPr lang="en-IN" dirty="0"/>
+              <a:t>: 10</a:t>
+            </a:r>
+          </a:p>
+          <a:p>
+            <a:r>
+              <a:rPr lang="en-IN" dirty="0"/>
+              <a:t>- </a:t>
+            </a:r>
+            <a:r>
+              <a:rPr lang="en-IN" dirty="0" err="1"/>
+              <a:t>min_samples_leaf</a:t>
+            </a:r>
+            <a:r>
+              <a:rPr lang="en-IN" dirty="0"/>
+              <a:t>: 5</a:t>
+            </a:r>
+          </a:p>
+          <a:p>
+            <a:r>
+              <a:rPr lang="en-IN" dirty="0"/>
+              <a:t>- </a:t>
+            </a:r>
+            <a:r>
+              <a:rPr lang="en-IN" dirty="0" err="1"/>
+              <a:t>class_weight</a:t>
+            </a:r>
+            <a:r>
+              <a:rPr lang="en-IN" dirty="0"/>
+              <a:t>: 'balanced'</a:t>
+            </a:r>
+          </a:p>
+          <a:p>
+            <a:r>
+              <a:rPr lang="en-IN" dirty="0"/>
+              <a:t>- </a:t>
+            </a:r>
+            <a:r>
+              <a:rPr lang="en-IN" dirty="0" err="1"/>
+              <a:t>n_jobs</a:t>
+            </a:r>
+            <a:r>
+              <a:rPr lang="en-IN" dirty="0"/>
+              <a:t>: 1 (single thread)</a:t>
+            </a:r>
+          </a:p>
+          <a:p>
+            <a:r>
+              <a:rPr lang="en-IN" dirty="0"/>
+              <a:t>- Same 7 features as Isolation Forest</a:t>
+            </a:r>
+          </a:p>
+          <a:p>
+            <a:r>
+              <a:rPr lang="en-IN" dirty="0"/>
+              <a:t>- Train/test split: 80/20 (stratified)</a:t>
+            </a:r>
+          </a:p>
+          <a:p>
+            <a:endParaRPr lang="en-IN" dirty="0"/>
+          </a:p>
+        </p:txBody>
+      </p:sp>
+      <p:pic>
+        <p:nvPicPr>
+          <p:cNvPr id="5" name="Picture 4">
+            <a:extLst>
+              <a:ext uri="{FF2B5EF4-FFF2-40B4-BE49-F238E27FC236}">
+                <a16:creationId xmlns:a16="http://schemas.microsoft.com/office/drawing/2014/main" id="{0AB5A529-501E-2519-F572-BC048B13DB02}"/>
+              </a:ext>
+            </a:extLst>
+          </p:cNvPr>
+          <p:cNvPicPr>
+            <a:picLocks noChangeAspect="1"/>
+          </p:cNvPicPr>
+          <p:nvPr/>
+        </p:nvPicPr>
+        <p:blipFill>
+          <a:blip r:embed="rId2"/>
+          <a:stretch>
+            <a:fillRect/>
+          </a:stretch>
+        </p:blipFill>
+        <p:spPr>
+          <a:xfrm>
+            <a:off x="4086091" y="2423067"/>
+            <a:ext cx="4168501" cy="2370025"/>
+          </a:xfrm>
+          <a:prstGeom prst="rect">
+            <a:avLst/>
+          </a:prstGeom>
+        </p:spPr>
+      </p:pic>
+    </p:spTree>
+    <p:extLst>
+      <p:ext uri="{BB962C8B-B14F-4D97-AF65-F5344CB8AC3E}">
+        <p14:creationId xmlns:p14="http://schemas.microsoft.com/office/powerpoint/2010/main" val="1630137038"/>
+      </p:ext>
+    </p:extLst>
+  </p:cSld>
+  <p:clrMapOvr>
+    <a:masterClrMapping/>
+  </p:clrMapOvr>
+</p:sld>
+</file>
+
+<file path=ppt/slides/slide24.xml><?xml version="1.0" encoding="utf-8"?>
+<p:sld xmlns:a="http://schemas.openxmlformats.org/drawingml/2006/main" xmlns:r="http://schemas.openxmlformats.org/officeDocument/2006/relationships" xmlns:p="http://schemas.openxmlformats.org/presentationml/2006/main">
+  <p:cSld>
+    <p:spTree>
+      <p:nvGrpSpPr>
+        <p:cNvPr id="1" name=""/>
+        <p:cNvGrpSpPr/>
+        <p:nvPr/>
+      </p:nvGrpSpPr>
+      <p:grpSpPr>
+        <a:xfrm>
+          <a:off x="0" y="0"/>
+          <a:ext cx="0" cy="0"/>
+          <a:chOff x="0" y="0"/>
+          <a:chExt cx="0" cy="0"/>
+        </a:xfrm>
+      </p:grpSpPr>
+      <p:sp>
+        <p:nvSpPr>
+          <p:cNvPr id="2" name="Title 1">
+            <a:extLst>
+              <a:ext uri="{FF2B5EF4-FFF2-40B4-BE49-F238E27FC236}">
+                <a16:creationId xmlns:a16="http://schemas.microsoft.com/office/drawing/2014/main" id="{22BDE856-C63A-4B10-4CFB-33E36F7C5A6A}"/>
+              </a:ext>
+            </a:extLst>
+          </p:cNvPr>
+          <p:cNvSpPr>
+            <a:spLocks noGrp="1"/>
+          </p:cNvSpPr>
+          <p:nvPr>
+            <p:ph type="title"/>
+          </p:nvPr>
+        </p:nvSpPr>
+        <p:spPr/>
+        <p:txBody>
+          <a:bodyPr>
+            <a:normAutofit fontScale="90000"/>
+          </a:bodyPr>
+          <a:lstStyle/>
+          <a:p>
+            <a:r>
+              <a:rPr lang="en-IN" dirty="0"/>
+              <a:t>Observations </a:t>
+            </a:r>
+          </a:p>
+        </p:txBody>
+      </p:sp>
+      <p:sp>
+        <p:nvSpPr>
+          <p:cNvPr id="3" name="Text Placeholder 2">
+            <a:extLst>
+              <a:ext uri="{FF2B5EF4-FFF2-40B4-BE49-F238E27FC236}">
+                <a16:creationId xmlns:a16="http://schemas.microsoft.com/office/drawing/2014/main" id="{33A31C01-004F-967D-4EF1-6C2233BA85E8}"/>
+              </a:ext>
+            </a:extLst>
+          </p:cNvPr>
+          <p:cNvSpPr>
+            <a:spLocks noGrp="1"/>
+          </p:cNvSpPr>
+          <p:nvPr>
+            <p:ph type="body" idx="1"/>
+          </p:nvPr>
+        </p:nvSpPr>
+        <p:spPr/>
+        <p:txBody>
           <a:bodyPr/>
           <a:lstStyle/>
+          <a:p>
+            <a:r>
+              <a:rPr lang="en-IN" b="1" dirty="0"/>
+              <a:t>Precision :</a:t>
+            </a:r>
+            <a:r>
+              <a:rPr lang="en-IN" dirty="0"/>
+              <a:t> Random Forest achieves a 100% precision score compared to Isolation Forest’s 0.18%, completely eliminating false flags.</a:t>
+            </a:r>
+          </a:p>
+          <a:p>
+            <a:r>
+              <a:rPr lang="en-IN" b="1" dirty="0"/>
+              <a:t>The Recall:</a:t>
+            </a:r>
+            <a:r>
+              <a:rPr lang="en-IN" dirty="0"/>
+              <a:t> Random Forest missed 8 out of 20 anomalies in the test set, dropping recall from 78.32% to 60.00%.</a:t>
+            </a:r>
+          </a:p>
+          <a:p>
+            <a:r>
+              <a:rPr lang="en-IN" b="1" dirty="0"/>
+              <a:t>Data Dependency:</a:t>
+            </a:r>
+            <a:r>
+              <a:rPr lang="en-IN" dirty="0"/>
+              <a:t> Random Forest requires explicit </a:t>
+            </a:r>
+            <a:r>
+              <a:rPr lang="en-IN" dirty="0" err="1"/>
+              <a:t>labeled</a:t>
+            </a:r>
+            <a:r>
+              <a:rPr lang="en-IN" dirty="0"/>
+              <a:t> history and training optimization on subsets, whereas Isolation Forest handles raw, </a:t>
+            </a:r>
+            <a:r>
+              <a:rPr lang="en-IN" dirty="0" err="1"/>
+              <a:t>unlabeled</a:t>
+            </a:r>
+            <a:r>
+              <a:rPr lang="en-IN" dirty="0"/>
+              <a:t> streams out of the box.</a:t>
+            </a:r>
+          </a:p>
           <a:p>
             <a:endParaRPr lang="en-IN" dirty="0"/>
           </a:p>
@@ -11278,7 +11695,282 @@
     </p:spTree>
     <p:extLst>
       <p:ext uri="{BB962C8B-B14F-4D97-AF65-F5344CB8AC3E}">
-        <p14:creationId xmlns:p14="http://schemas.microsoft.com/office/powerpoint/2010/main" val="1630137038"/>
+        <p14:creationId xmlns:p14="http://schemas.microsoft.com/office/powerpoint/2010/main" val="3112262530"/>
+      </p:ext>
+    </p:extLst>
+  </p:cSld>
+  <p:clrMapOvr>
+    <a:masterClrMapping/>
+  </p:clrMapOvr>
+</p:sld>
+</file>
+
+<file path=ppt/slides/slide25.xml><?xml version="1.0" encoding="utf-8"?>
+<p:sld xmlns:a="http://schemas.openxmlformats.org/drawingml/2006/main" xmlns:r="http://schemas.openxmlformats.org/officeDocument/2006/relationships" xmlns:p="http://schemas.openxmlformats.org/presentationml/2006/main">
+  <p:cSld>
+    <p:spTree>
+      <p:nvGrpSpPr>
+        <p:cNvPr id="1" name=""/>
+        <p:cNvGrpSpPr/>
+        <p:nvPr/>
+      </p:nvGrpSpPr>
+      <p:grpSpPr>
+        <a:xfrm>
+          <a:off x="0" y="0"/>
+          <a:ext cx="0" cy="0"/>
+          <a:chOff x="0" y="0"/>
+          <a:chExt cx="0" cy="0"/>
+        </a:xfrm>
+      </p:grpSpPr>
+      <p:sp>
+        <p:nvSpPr>
+          <p:cNvPr id="2" name="Title 1">
+            <a:extLst>
+              <a:ext uri="{FF2B5EF4-FFF2-40B4-BE49-F238E27FC236}">
+                <a16:creationId xmlns:a16="http://schemas.microsoft.com/office/drawing/2014/main" id="{5227D442-719C-65AA-4470-9126BECBFB17}"/>
+              </a:ext>
+            </a:extLst>
+          </p:cNvPr>
+          <p:cNvSpPr>
+            <a:spLocks noGrp="1"/>
+          </p:cNvSpPr>
+          <p:nvPr>
+            <p:ph type="title"/>
+          </p:nvPr>
+        </p:nvSpPr>
+        <p:spPr/>
+        <p:txBody>
+          <a:bodyPr>
+            <a:normAutofit fontScale="90000"/>
+          </a:bodyPr>
+          <a:lstStyle/>
+          <a:p>
+            <a:r>
+              <a:rPr lang="en-IN" dirty="0"/>
+              <a:t>Supervised Learning - Streaming</a:t>
+            </a:r>
+          </a:p>
+        </p:txBody>
+      </p:sp>
+      <p:sp>
+        <p:nvSpPr>
+          <p:cNvPr id="3" name="Text Placeholder 2">
+            <a:extLst>
+              <a:ext uri="{FF2B5EF4-FFF2-40B4-BE49-F238E27FC236}">
+                <a16:creationId xmlns:a16="http://schemas.microsoft.com/office/drawing/2014/main" id="{87E0656D-9CA4-CCF0-91E8-660097AB0EB5}"/>
+              </a:ext>
+            </a:extLst>
+          </p:cNvPr>
+          <p:cNvSpPr>
+            <a:spLocks noGrp="1"/>
+          </p:cNvSpPr>
+          <p:nvPr>
+            <p:ph type="body" idx="1"/>
+          </p:nvPr>
+        </p:nvSpPr>
+        <p:spPr/>
+        <p:txBody>
+          <a:bodyPr/>
+          <a:lstStyle/>
+          <a:p>
+            <a:r>
+              <a:rPr lang="en-IN" dirty="0"/>
+              <a:t>The trained model used on streaming data.</a:t>
+            </a:r>
+          </a:p>
+          <a:p>
+            <a:r>
+              <a:rPr lang="en-IN" dirty="0"/>
+              <a:t>The result seen in batch is transferred</a:t>
+            </a:r>
+            <a:br>
+              <a:rPr lang="en-IN" dirty="0"/>
+            </a:br>
+            <a:r>
+              <a:rPr lang="en-IN" dirty="0"/>
+              <a:t>to Streaming as well.</a:t>
+            </a:r>
+          </a:p>
+        </p:txBody>
+      </p:sp>
+      <p:pic>
+        <p:nvPicPr>
+          <p:cNvPr id="7" name="Picture 6">
+            <a:extLst>
+              <a:ext uri="{FF2B5EF4-FFF2-40B4-BE49-F238E27FC236}">
+                <a16:creationId xmlns:a16="http://schemas.microsoft.com/office/drawing/2014/main" id="{FEAB387D-8C0D-9CC4-83C4-9477FDBA3194}"/>
+              </a:ext>
+            </a:extLst>
+          </p:cNvPr>
+          <p:cNvPicPr>
+            <a:picLocks noChangeAspect="1"/>
+          </p:cNvPicPr>
+          <p:nvPr/>
+        </p:nvPicPr>
+        <p:blipFill>
+          <a:blip r:embed="rId2"/>
+          <a:stretch>
+            <a:fillRect/>
+          </a:stretch>
+        </p:blipFill>
+        <p:spPr>
+          <a:xfrm>
+            <a:off x="201283" y="2912444"/>
+            <a:ext cx="4206605" cy="1920406"/>
+          </a:xfrm>
+          <a:prstGeom prst="rect">
+            <a:avLst/>
+          </a:prstGeom>
+        </p:spPr>
+      </p:pic>
+      <p:pic>
+        <p:nvPicPr>
+          <p:cNvPr id="5" name="Picture 4">
+            <a:extLst>
+              <a:ext uri="{FF2B5EF4-FFF2-40B4-BE49-F238E27FC236}">
+                <a16:creationId xmlns:a16="http://schemas.microsoft.com/office/drawing/2014/main" id="{F325F47F-0086-51C3-9877-EFA8F7258E08}"/>
+              </a:ext>
+            </a:extLst>
+          </p:cNvPr>
+          <p:cNvPicPr>
+            <a:picLocks noChangeAspect="1"/>
+          </p:cNvPicPr>
+          <p:nvPr/>
+        </p:nvPicPr>
+        <p:blipFill>
+          <a:blip r:embed="rId3"/>
+          <a:stretch>
+            <a:fillRect/>
+          </a:stretch>
+        </p:blipFill>
+        <p:spPr>
+          <a:xfrm>
+            <a:off x="4042994" y="2683824"/>
+            <a:ext cx="4740051" cy="2149026"/>
+          </a:xfrm>
+          <a:prstGeom prst="rect">
+            <a:avLst/>
+          </a:prstGeom>
+        </p:spPr>
+      </p:pic>
+    </p:spTree>
+    <p:extLst>
+      <p:ext uri="{BB962C8B-B14F-4D97-AF65-F5344CB8AC3E}">
+        <p14:creationId xmlns:p14="http://schemas.microsoft.com/office/powerpoint/2010/main" val="2945472335"/>
+      </p:ext>
+    </p:extLst>
+  </p:cSld>
+  <p:clrMapOvr>
+    <a:masterClrMapping/>
+  </p:clrMapOvr>
+</p:sld>
+</file>
+
+<file path=ppt/slides/slide26.xml><?xml version="1.0" encoding="utf-8"?>
+<p:sld xmlns:a="http://schemas.openxmlformats.org/drawingml/2006/main" xmlns:r="http://schemas.openxmlformats.org/officeDocument/2006/relationships" xmlns:p="http://schemas.openxmlformats.org/presentationml/2006/main">
+  <p:cSld>
+    <p:spTree>
+      <p:nvGrpSpPr>
+        <p:cNvPr id="1" name=""/>
+        <p:cNvGrpSpPr/>
+        <p:nvPr/>
+      </p:nvGrpSpPr>
+      <p:grpSpPr>
+        <a:xfrm>
+          <a:off x="0" y="0"/>
+          <a:ext cx="0" cy="0"/>
+          <a:chOff x="0" y="0"/>
+          <a:chExt cx="0" cy="0"/>
+        </a:xfrm>
+      </p:grpSpPr>
+      <p:sp>
+        <p:nvSpPr>
+          <p:cNvPr id="2" name="Title 1">
+            <a:extLst>
+              <a:ext uri="{FF2B5EF4-FFF2-40B4-BE49-F238E27FC236}">
+                <a16:creationId xmlns:a16="http://schemas.microsoft.com/office/drawing/2014/main" id="{3629E79B-02A5-4A95-6233-A7C48BEDD2B2}"/>
+              </a:ext>
+            </a:extLst>
+          </p:cNvPr>
+          <p:cNvSpPr>
+            <a:spLocks noGrp="1"/>
+          </p:cNvSpPr>
+          <p:nvPr>
+            <p:ph type="title"/>
+          </p:nvPr>
+        </p:nvSpPr>
+        <p:spPr/>
+        <p:txBody>
+          <a:bodyPr>
+            <a:normAutofit fontScale="90000"/>
+          </a:bodyPr>
+          <a:lstStyle/>
+          <a:p>
+            <a:r>
+              <a:rPr lang="en-IN" dirty="0"/>
+              <a:t>Plan for next week (28 June to 4 July)</a:t>
+            </a:r>
+          </a:p>
+        </p:txBody>
+      </p:sp>
+      <p:sp>
+        <p:nvSpPr>
+          <p:cNvPr id="3" name="Text Placeholder 2">
+            <a:extLst>
+              <a:ext uri="{FF2B5EF4-FFF2-40B4-BE49-F238E27FC236}">
+                <a16:creationId xmlns:a16="http://schemas.microsoft.com/office/drawing/2014/main" id="{A5967385-7EF5-732F-439B-B496A8181E71}"/>
+              </a:ext>
+            </a:extLst>
+          </p:cNvPr>
+          <p:cNvSpPr>
+            <a:spLocks noGrp="1"/>
+          </p:cNvSpPr>
+          <p:nvPr>
+            <p:ph type="body" idx="1"/>
+          </p:nvPr>
+        </p:nvSpPr>
+        <p:spPr/>
+        <p:txBody>
+          <a:bodyPr/>
+          <a:lstStyle/>
+          <a:p>
+            <a:r>
+              <a:rPr lang="en-IN" dirty="0"/>
+              <a:t>Current training of model was on subset of data. Will try using the entire dataset to see if it has better impact of the result</a:t>
+            </a:r>
+          </a:p>
+          <a:p>
+            <a:r>
+              <a:rPr lang="en-IN" dirty="0"/>
+              <a:t>Hyperparameter Tuning for Higher Recall</a:t>
+            </a:r>
+          </a:p>
+          <a:p>
+            <a:r>
+              <a:rPr lang="en-IN" dirty="0"/>
+              <a:t>Try getting better features</a:t>
+            </a:r>
+          </a:p>
+          <a:p>
+            <a:r>
+              <a:rPr lang="en-IN" dirty="0"/>
+              <a:t>Will try with different </a:t>
+            </a:r>
+            <a:r>
+              <a:rPr lang="en-IN"/>
+              <a:t>basic models, DL and LLM</a:t>
+            </a:r>
+            <a:endParaRPr lang="en-IN" dirty="0"/>
+          </a:p>
+          <a:p>
+            <a:endParaRPr lang="en-IN" dirty="0"/>
+          </a:p>
+        </p:txBody>
+      </p:sp>
+    </p:spTree>
+    <p:extLst>
+      <p:ext uri="{BB962C8B-B14F-4D97-AF65-F5344CB8AC3E}">
+        <p14:creationId xmlns:p14="http://schemas.microsoft.com/office/powerpoint/2010/main" val="2923701509"/>
       </p:ext>
     </p:extLst>
   </p:cSld>

</xml_diff>